<commit_message>
Use real entity logos and fix Ras Al-Khair symbol crop
- Cover shows the RCJY, Jabeen and Rqeem logos in that order
- Slide 5 shows the RCJY logo next to the colour source line
- Closing slide shows the Rqeem logo above the development credit
- Crop city motifs at the real gap so the Ras Al-Khair shape is complete

Co-Authored-By: Claude Opus 5.5 <noreply@anthropic.com>
Claude-Session: https://claude.ai/code/session_01P1oeWKb56uta6kCwy9Py2o
</commit_message>
<xml_diff>
--- a/nafitha-afrad/nafitha-afrad.pptx
+++ b/nafitha-afrad/nafitha-afrad.pptx
@@ -2186,25 +2186,45 @@
           </a:p>
         </p:txBody>
       </p:sp>
-      <p:sp>
-        <p:nvSpPr>
-          <p:cNvPr id="7" name="anim4_3"/>
+      <p:pic>
+        <p:nvPicPr>
+          <p:cNvPr id="7" name="anim4_3" descr="شعار الهيئة الملكية للجبيل وينبع">    </p:cNvPr>
+          <p:cNvPicPr>
+            <a:picLocks noChangeAspect="1"/>
+          </p:cNvPicPr>
+          <p:nvPr/>
+        </p:nvPicPr>
+        <p:blipFill>
+          <a:blip r:embed="rId4"/>
+          <a:stretch>
+            <a:fillRect/>
+          </a:stretch>
+        </p:blipFill>
+        <p:spPr>
+          <a:xfrm>
+            <a:off x="7784534" y="5074920"/>
+            <a:ext cx="1145854" cy="868680"/>
+          </a:xfrm>
+          <a:prstGeom prst="rect">
+            <a:avLst/>
+          </a:prstGeom>
+        </p:spPr>
+      </p:pic>
+      <p:sp>
+        <p:nvSpPr>
+          <p:cNvPr id="8" name="anim4_4"/>
           <p:cNvSpPr/>
           <p:nvPr/>
         </p:nvSpPr>
         <p:spPr>
           <a:xfrm>
-            <a:off x="7787488" y="5257800"/>
-            <a:ext cx="2743200" cy="777240"/>
-          </a:xfrm>
-          <a:prstGeom prst="roundRect">
-            <a:avLst>
-              <a:gd name="adj" fmla="val 14118"/>
-            </a:avLst>
-          </a:prstGeom>
-          <a:solidFill>
-            <a:srgbClr val="FFFFFF"/>
-          </a:solidFill>
+            <a:off x="7281614" y="5166360"/>
+            <a:ext cx="0" cy="685800"/>
+          </a:xfrm>
+          <a:prstGeom prst="line">
+            <a:avLst/>
+          </a:prstGeom>
+          <a:noFill/>
           <a:ln w="12700">
             <a:solidFill>
               <a:srgbClr val="D6DEEE"/>
@@ -2213,64 +2233,45 @@
           </a:ln>
         </p:spPr>
       </p:sp>
-      <p:sp>
-        <p:nvSpPr>
-          <p:cNvPr id="8" name="anim4_4"/>
-          <p:cNvSpPr txBox="1"/>
-          <p:nvPr/>
-        </p:nvSpPr>
-        <p:spPr>
-          <a:xfrm>
-            <a:off x="7878928" y="5257800"/>
-            <a:ext cx="2560320" cy="777240"/>
-          </a:xfrm>
-          <a:prstGeom prst="rect">
+      <p:pic>
+        <p:nvPicPr>
+          <p:cNvPr id="9" name="anim4_5" descr="شعار جبين">    </p:cNvPr>
+          <p:cNvPicPr>
+            <a:picLocks noChangeAspect="1"/>
+          </p:cNvPicPr>
+          <p:nvPr/>
+        </p:nvPicPr>
+        <p:blipFill>
+          <a:blip r:embed="rId5"/>
+          <a:stretch>
+            <a:fillRect/>
+          </a:stretch>
+        </p:blipFill>
+        <p:spPr>
+          <a:xfrm>
+            <a:off x="5537722" y="5074920"/>
+            <a:ext cx="1240971" cy="868680"/>
+          </a:xfrm>
+          <a:prstGeom prst="rect">
+            <a:avLst/>
+          </a:prstGeom>
+        </p:spPr>
+      </p:pic>
+      <p:sp>
+        <p:nvSpPr>
+          <p:cNvPr id="10" name="anim4_6"/>
+          <p:cNvSpPr/>
+          <p:nvPr/>
+        </p:nvSpPr>
+        <p:spPr>
+          <a:xfrm>
+            <a:off x="5034802" y="5166360"/>
+            <a:ext cx="0" cy="685800"/>
+          </a:xfrm>
+          <a:prstGeom prst="line">
             <a:avLst/>
           </a:prstGeom>
           <a:noFill/>
-          <a:ln/>
-        </p:spPr>
-        <p:txBody>
-          <a:bodyPr wrap="square" lIns="0" tIns="0" rIns="0" bIns="0" rtlCol="0" anchor="ctr"/>
-          <a:lstStyle/>
-          <a:p>
-            <a:pPr rtl="1" algn="ctr" indent="0" marL="0">
-              <a:buNone/>
-            </a:pPr>
-            <a:r>
-              <a:rPr lang="ar-SA" altLang="en-US" sz="1400" b="1" dirty="0">
-                <a:solidFill>
-                  <a:srgbClr val="052977"/>
-                </a:solidFill>
-                <a:latin typeface="Cairo" pitchFamily="34" charset="0"/>
-                <a:ea typeface="Cairo" pitchFamily="34" charset="-122"/>
-                <a:cs typeface="Cairo" pitchFamily="34" charset="-120"/>
-              </a:rPr>
-              <a:t>الهيئة الملكية للجبيل وينبع</a:t>
-            </a:r>
-            <a:endParaRPr lang="ar-SA" sz="1400" dirty="0"/>
-          </a:p>
-        </p:txBody>
-      </p:sp>
-      <p:sp>
-        <p:nvSpPr>
-          <p:cNvPr id="9" name="anim4_5"/>
-          <p:cNvSpPr/>
-          <p:nvPr/>
-        </p:nvSpPr>
-        <p:spPr>
-          <a:xfrm>
-            <a:off x="4724248" y="5257800"/>
-            <a:ext cx="2743200" cy="777240"/>
-          </a:xfrm>
-          <a:prstGeom prst="roundRect">
-            <a:avLst>
-              <a:gd name="adj" fmla="val 14118"/>
-            </a:avLst>
-          </a:prstGeom>
-          <a:solidFill>
-            <a:srgbClr val="FFFFFF"/>
-          </a:solidFill>
           <a:ln w="12700">
             <a:solidFill>
               <a:srgbClr val="D6DEEE"/>
@@ -2279,111 +2280,30 @@
           </a:ln>
         </p:spPr>
       </p:sp>
-      <p:sp>
-        <p:nvSpPr>
-          <p:cNvPr id="10" name="anim4_6"/>
-          <p:cNvSpPr txBox="1"/>
-          <p:nvPr/>
-        </p:nvSpPr>
-        <p:spPr>
-          <a:xfrm>
-            <a:off x="4815688" y="5257800"/>
-            <a:ext cx="2560320" cy="777240"/>
-          </a:xfrm>
-          <a:prstGeom prst="rect">
-            <a:avLst/>
-          </a:prstGeom>
-          <a:noFill/>
-          <a:ln/>
-        </p:spPr>
-        <p:txBody>
-          <a:bodyPr wrap="square" lIns="0" tIns="0" rIns="0" bIns="0" rtlCol="0" anchor="ctr"/>
-          <a:lstStyle/>
-          <a:p>
-            <a:pPr rtl="1" algn="ctr" indent="0" marL="0">
-              <a:buNone/>
-            </a:pPr>
-            <a:r>
-              <a:rPr lang="ar-SA" altLang="en-US" sz="1400" b="1" dirty="0">
-                <a:solidFill>
-                  <a:srgbClr val="052977"/>
-                </a:solidFill>
-                <a:latin typeface="Cairo" pitchFamily="34" charset="0"/>
-                <a:ea typeface="Cairo" pitchFamily="34" charset="-122"/>
-                <a:cs typeface="Cairo" pitchFamily="34" charset="-120"/>
-              </a:rPr>
-              <a:t>جبين</a:t>
-            </a:r>
-            <a:endParaRPr lang="ar-SA" sz="1400" dirty="0"/>
-          </a:p>
-        </p:txBody>
-      </p:sp>
-      <p:sp>
-        <p:nvSpPr>
-          <p:cNvPr id="11" name="anim4_7"/>
-          <p:cNvSpPr/>
-          <p:nvPr/>
-        </p:nvSpPr>
-        <p:spPr>
-          <a:xfrm>
-            <a:off x="1661008" y="5257800"/>
-            <a:ext cx="2743200" cy="777240"/>
-          </a:xfrm>
-          <a:prstGeom prst="roundRect">
-            <a:avLst>
-              <a:gd name="adj" fmla="val 14118"/>
-            </a:avLst>
-          </a:prstGeom>
-          <a:solidFill>
-            <a:srgbClr val="FFFFFF"/>
-          </a:solidFill>
-          <a:ln w="12700">
-            <a:solidFill>
-              <a:srgbClr val="D6DEEE"/>
-            </a:solidFill>
-            <a:prstDash val="solid"/>
-          </a:ln>
-        </p:spPr>
-      </p:sp>
-      <p:sp>
-        <p:nvSpPr>
-          <p:cNvPr id="12" name="anim4_8"/>
-          <p:cNvSpPr txBox="1"/>
-          <p:nvPr/>
-        </p:nvSpPr>
-        <p:spPr>
-          <a:xfrm>
-            <a:off x="1752448" y="5257800"/>
-            <a:ext cx="2560320" cy="777240"/>
-          </a:xfrm>
-          <a:prstGeom prst="rect">
-            <a:avLst/>
-          </a:prstGeom>
-          <a:noFill/>
-          <a:ln/>
-        </p:spPr>
-        <p:txBody>
-          <a:bodyPr wrap="square" lIns="0" tIns="0" rIns="0" bIns="0" rtlCol="0" anchor="ctr"/>
-          <a:lstStyle/>
-          <a:p>
-            <a:pPr rtl="1" algn="ctr" indent="0" marL="0">
-              <a:buNone/>
-            </a:pPr>
-            <a:r>
-              <a:rPr lang="ar-SA" altLang="en-US" sz="1400" b="1" dirty="0">
-                <a:solidFill>
-                  <a:srgbClr val="052977"/>
-                </a:solidFill>
-                <a:latin typeface="Cairo" pitchFamily="34" charset="0"/>
-                <a:ea typeface="Cairo" pitchFamily="34" charset="-122"/>
-                <a:cs typeface="Cairo" pitchFamily="34" charset="-120"/>
-              </a:rPr>
-              <a:t>رقيم للحلول الذكية</a:t>
-            </a:r>
-            <a:endParaRPr lang="ar-SA" sz="1400" dirty="0"/>
-          </a:p>
-        </p:txBody>
-      </p:sp>
+      <p:pic>
+        <p:nvPicPr>
+          <p:cNvPr id="11" name="anim4_7" descr="شعار رقيم للحلول الذكية">    </p:cNvPr>
+          <p:cNvPicPr>
+            <a:picLocks noChangeAspect="1"/>
+          </p:cNvPicPr>
+          <p:nvPr/>
+        </p:nvPicPr>
+        <p:blipFill>
+          <a:blip r:embed="rId6"/>
+          <a:stretch>
+            <a:fillRect/>
+          </a:stretch>
+        </p:blipFill>
+        <p:spPr>
+          <a:xfrm>
+            <a:off x="3261307" y="5074920"/>
+            <a:ext cx="1270575" cy="868680"/>
+          </a:xfrm>
+          <a:prstGeom prst="rect">
+            <a:avLst/>
+          </a:prstGeom>
+        </p:spPr>
+      </p:pic>
     </p:spTree>
   </p:cSld>
   <p:clrMapOvr>
@@ -2401,7 +2321,7 @@
               <p:cTn id="2" dur="indefinite" nodeType="mainSeq">
                 <p:childTnLst>
                   <p:par>
-                    <p:cTn id="34" fill="hold">
+                    <p:cTn id="31" fill="hold">
                       <p:stCondLst>
                         <p:cond delay="indefinite"/>
                         <p:cond evt="onBegin" delay="0">
@@ -2542,7 +2462,7 @@
                           </p:cTn>
                         </p:par>
                         <p:par>
-                          <p:cTn id="33" fill="hold">
+                          <p:cTn id="30" fill="hold">
                             <p:stCondLst>
                               <p:cond delay="2100"/>
                             </p:stCondLst>
@@ -2716,41 +2636,6 @@
                                         <p:cTn id="29" dur="450"/>
                                         <p:tgtEl>
                                           <p:spTgt spid="11"/>
-                                        </p:tgtEl>
-                                      </p:cBhvr>
-                                    </p:animEffect>
-                                  </p:childTnLst>
-                                </p:cTn>
-                              </p:par>
-                              <p:par>
-                                <p:cTn id="30" presetID="10" presetClass="entr" presetSubtype="0" fill="hold" grpId="0" nodeType="withEffect">
-                                  <p:stCondLst>
-                                    <p:cond delay="0"/>
-                                  </p:stCondLst>
-                                  <p:childTnLst>
-                                    <p:set>
-                                      <p:cBhvr>
-                                        <p:cTn id="31" dur="1" fill="hold">
-                                          <p:stCondLst>
-                                            <p:cond delay="0"/>
-                                          </p:stCondLst>
-                                        </p:cTn>
-                                        <p:tgtEl>
-                                          <p:spTgt spid="12"/>
-                                        </p:tgtEl>
-                                        <p:attrNameLst>
-                                          <p:attrName>style.visibility</p:attrName>
-                                        </p:attrNameLst>
-                                      </p:cBhvr>
-                                      <p:to>
-                                        <p:strVal val="visible"/>
-                                      </p:to>
-                                    </p:set>
-                                    <p:animEffect transition="in" filter="fade">
-                                      <p:cBhvr>
-                                        <p:cTn id="32" dur="450"/>
-                                        <p:tgtEl>
-                                          <p:spTgt spid="12"/>
                                         </p:tgtEl>
                                       </p:cBhvr>
                                     </p:animEffect>
@@ -2787,12 +2672,8 @@
     <p:bldLst>
       <p:bldP spid="5" grpId="0" animBg="1"/>
       <p:bldP spid="6" grpId="0" animBg="1"/>
-      <p:bldP spid="7" grpId="0" animBg="1"/>
       <p:bldP spid="8" grpId="0" animBg="1"/>
-      <p:bldP spid="9" grpId="0" animBg="1"/>
       <p:bldP spid="10" grpId="0" animBg="1"/>
-      <p:bldP spid="11" grpId="0" animBg="1"/>
-      <p:bldP spid="12" grpId="0" animBg="1"/>
     </p:bldLst>
   </p:timing>
 </p:sld>
@@ -9432,16 +9313,40 @@
           </a:p>
         </p:txBody>
       </p:sp>
-      <p:sp>
-        <p:nvSpPr>
-          <p:cNvPr id="11" name="anim4_238"/>
+      <p:pic>
+        <p:nvPicPr>
+          <p:cNvPr id="11" name="anim4_238" descr="شعار رقيم للحلول الذكية">    </p:cNvPr>
+          <p:cNvPicPr>
+            <a:picLocks noChangeAspect="1"/>
+          </p:cNvPicPr>
+          <p:nvPr/>
+        </p:nvPicPr>
+        <p:blipFill>
+          <a:blip r:embed="rId5"/>
+          <a:stretch>
+            <a:fillRect/>
+          </a:stretch>
+        </p:blipFill>
+        <p:spPr>
+          <a:xfrm>
+            <a:off x="5627741" y="5257800"/>
+            <a:ext cx="936213" cy="640080"/>
+          </a:xfrm>
+          <a:prstGeom prst="rect">
+            <a:avLst/>
+          </a:prstGeom>
+        </p:spPr>
+      </p:pic>
+      <p:sp>
+        <p:nvSpPr>
+          <p:cNvPr id="12" name="anim4_239"/>
           <p:cNvSpPr txBox="1"/>
           <p:nvPr/>
         </p:nvSpPr>
         <p:spPr>
           <a:xfrm>
-            <a:off x="1828800" y="5989320"/>
-            <a:ext cx="8534095" cy="411480"/>
+            <a:off x="2743200" y="5989320"/>
+            <a:ext cx="6705295" cy="365760"/>
           </a:xfrm>
           <a:prstGeom prst="rect">
             <a:avLst/>
@@ -9450,7 +9355,7 @@
           <a:ln/>
         </p:spPr>
         <p:txBody>
-          <a:bodyPr wrap="square" lIns="0" tIns="0" rIns="0" bIns="0" rtlCol="0" anchor="t"/>
+          <a:bodyPr wrap="square" lIns="0" tIns="0" rIns="0" bIns="0" rtlCol="0" anchor="ctr"/>
           <a:lstStyle/>
           <a:p>
             <a:pPr rtl="1" algn="ctr" indent="0" marL="0">
@@ -9488,7 +9393,7 @@
               <p:cTn id="2" dur="indefinite" nodeType="mainSeq">
                 <p:childTnLst>
                   <p:par>
-                    <p:cTn id="31" fill="hold">
+                    <p:cTn id="34" fill="hold">
                       <p:stCondLst>
                         <p:cond delay="indefinite"/>
                         <p:cond evt="onBegin" delay="0">
@@ -9769,7 +9674,7 @@
                           </p:cTn>
                         </p:par>
                         <p:par>
-                          <p:cTn id="30" fill="hold">
+                          <p:cTn id="33" fill="hold">
                             <p:stCondLst>
                               <p:cond delay="2100"/>
                             </p:stCondLst>
@@ -9803,6 +9708,41 @@
                                         <p:cTn id="29" dur="450"/>
                                         <p:tgtEl>
                                           <p:spTgt spid="11"/>
+                                        </p:tgtEl>
+                                      </p:cBhvr>
+                                    </p:animEffect>
+                                  </p:childTnLst>
+                                </p:cTn>
+                              </p:par>
+                              <p:par>
+                                <p:cTn id="30" presetID="10" presetClass="entr" presetSubtype="0" fill="hold" grpId="0" nodeType="withEffect">
+                                  <p:stCondLst>
+                                    <p:cond delay="0"/>
+                                  </p:stCondLst>
+                                  <p:childTnLst>
+                                    <p:set>
+                                      <p:cBhvr>
+                                        <p:cTn id="31" dur="1" fill="hold">
+                                          <p:stCondLst>
+                                            <p:cond delay="0"/>
+                                          </p:stCondLst>
+                                        </p:cTn>
+                                        <p:tgtEl>
+                                          <p:spTgt spid="12"/>
+                                        </p:tgtEl>
+                                        <p:attrNameLst>
+                                          <p:attrName>style.visibility</p:attrName>
+                                        </p:attrNameLst>
+                                      </p:cBhvr>
+                                      <p:to>
+                                        <p:strVal val="visible"/>
+                                      </p:to>
+                                    </p:set>
+                                    <p:animEffect transition="in" filter="fade">
+                                      <p:cBhvr>
+                                        <p:cTn id="32" dur="450"/>
+                                        <p:tgtEl>
+                                          <p:spTgt spid="12"/>
                                         </p:tgtEl>
                                       </p:cBhvr>
                                     </p:animEffect>
@@ -9842,7 +9782,7 @@
       <p:bldP spid="7" grpId="0" animBg="1"/>
       <p:bldP spid="8" grpId="0" animBg="1"/>
       <p:bldP spid="10" grpId="0" animBg="1"/>
-      <p:bldP spid="11" grpId="0" animBg="1"/>
+      <p:bldP spid="12" grpId="0" animBg="1"/>
     </p:bldLst>
   </p:timing>
 </p:sld>
@@ -10080,7 +10020,7 @@
       </p:sp>
       <p:sp>
         <p:nvSpPr>
-          <p:cNvPr id="8" name="anim1_9"/>
+          <p:cNvPr id="8" name="anim1_8"/>
           <p:cNvSpPr/>
           <p:nvPr/>
         </p:nvSpPr>
@@ -10100,7 +10040,7 @@
       </p:sp>
       <p:pic>
         <p:nvPicPr>
-          <p:cNvPr id="9" name="anim1_10" descr="نافذة أفراد">    </p:cNvPr>
+          <p:cNvPr id="9" name="anim1_9" descr="نافذة أفراد">    </p:cNvPr>
           <p:cNvPicPr>
             <a:picLocks noChangeAspect="1"/>
           </p:cNvPicPr>
@@ -10124,7 +10064,7 @@
       </p:pic>
       <p:sp>
         <p:nvSpPr>
-          <p:cNvPr id="10" name="anim2_11"/>
+          <p:cNvPr id="10" name="anim2_10"/>
           <p:cNvSpPr txBox="1"/>
           <p:nvPr/>
         </p:nvSpPr>
@@ -10163,7 +10103,7 @@
       </p:sp>
       <p:sp>
         <p:nvSpPr>
-          <p:cNvPr id="11" name="anim3_12"/>
+          <p:cNvPr id="11" name="anim3_11"/>
           <p:cNvSpPr/>
           <p:nvPr/>
         </p:nvSpPr>
@@ -10183,7 +10123,7 @@
       </p:sp>
       <p:pic>
         <p:nvPicPr>
-          <p:cNvPr id="12" name="anim3_13" descr="نافذة أفراد">    </p:cNvPr>
+          <p:cNvPr id="12" name="anim3_12" descr="نافذة أفراد">    </p:cNvPr>
           <p:cNvPicPr>
             <a:picLocks noChangeAspect="1"/>
           </p:cNvPicPr>
@@ -10207,7 +10147,7 @@
       </p:pic>
       <p:sp>
         <p:nvSpPr>
-          <p:cNvPr id="13" name="anim3_14"/>
+          <p:cNvPr id="13" name="anim3_13"/>
           <p:cNvSpPr txBox="1"/>
           <p:nvPr/>
         </p:nvSpPr>
@@ -10246,7 +10186,7 @@
       </p:sp>
       <p:sp>
         <p:nvSpPr>
-          <p:cNvPr id="14" name="anim3_15"/>
+          <p:cNvPr id="14" name="anim3_14"/>
           <p:cNvSpPr txBox="1"/>
           <p:nvPr/>
         </p:nvSpPr>
@@ -10285,7 +10225,7 @@
       </p:sp>
       <p:sp>
         <p:nvSpPr>
-          <p:cNvPr id="15" name="anim4_16"/>
+          <p:cNvPr id="15" name="anim4_15"/>
           <p:cNvSpPr/>
           <p:nvPr/>
         </p:nvSpPr>
@@ -10305,7 +10245,7 @@
       </p:sp>
       <p:pic>
         <p:nvPicPr>
-          <p:cNvPr id="16" name="anim4_17" descr="نافذة أفراد">    </p:cNvPr>
+          <p:cNvPr id="16" name="anim4_16" descr="نافذة أفراد">    </p:cNvPr>
           <p:cNvPicPr>
             <a:picLocks noChangeAspect="1"/>
           </p:cNvPicPr>
@@ -10329,7 +10269,7 @@
       </p:pic>
       <p:sp>
         <p:nvSpPr>
-          <p:cNvPr id="17" name="anim4_18"/>
+          <p:cNvPr id="17" name="anim4_17"/>
           <p:cNvSpPr txBox="1"/>
           <p:nvPr/>
         </p:nvSpPr>
@@ -10368,7 +10308,7 @@
       </p:sp>
       <p:sp>
         <p:nvSpPr>
-          <p:cNvPr id="18" name="anim4_19"/>
+          <p:cNvPr id="18" name="anim4_18"/>
           <p:cNvSpPr txBox="1"/>
           <p:nvPr/>
         </p:nvSpPr>
@@ -10407,7 +10347,7 @@
       </p:sp>
       <p:sp>
         <p:nvSpPr>
-          <p:cNvPr id="19" name="anim5_20"/>
+          <p:cNvPr id="19" name="anim5_19"/>
           <p:cNvSpPr/>
           <p:nvPr/>
         </p:nvSpPr>
@@ -10427,7 +10367,7 @@
       </p:sp>
       <p:pic>
         <p:nvPicPr>
-          <p:cNvPr id="20" name="anim5_21" descr="نافذة أفراد">    </p:cNvPr>
+          <p:cNvPr id="20" name="anim5_20" descr="نافذة أفراد">    </p:cNvPr>
           <p:cNvPicPr>
             <a:picLocks noChangeAspect="1"/>
           </p:cNvPicPr>
@@ -10451,7 +10391,7 @@
       </p:pic>
       <p:sp>
         <p:nvSpPr>
-          <p:cNvPr id="21" name="anim5_22"/>
+          <p:cNvPr id="21" name="anim5_21"/>
           <p:cNvSpPr txBox="1"/>
           <p:nvPr/>
         </p:nvSpPr>
@@ -10490,7 +10430,7 @@
       </p:sp>
       <p:sp>
         <p:nvSpPr>
-          <p:cNvPr id="22" name="anim5_23"/>
+          <p:cNvPr id="22" name="anim5_22"/>
           <p:cNvSpPr txBox="1"/>
           <p:nvPr/>
         </p:nvSpPr>
@@ -11395,7 +11335,7 @@
       </p:sp>
       <p:sp>
         <p:nvSpPr>
-          <p:cNvPr id="8" name="anim1_24"/>
+          <p:cNvPr id="8" name="anim1_23"/>
           <p:cNvSpPr/>
           <p:nvPr/>
         </p:nvSpPr>
@@ -11417,7 +11357,7 @@
       </p:sp>
       <p:sp>
         <p:nvSpPr>
-          <p:cNvPr id="9" name="anim1_25"/>
+          <p:cNvPr id="9" name="anim1_24"/>
           <p:cNvSpPr/>
           <p:nvPr/>
         </p:nvSpPr>
@@ -11437,7 +11377,7 @@
       </p:sp>
       <p:pic>
         <p:nvPicPr>
-          <p:cNvPr id="10" name="anim1_26" descr="نافذة أفراد">    </p:cNvPr>
+          <p:cNvPr id="10" name="anim1_25" descr="نافذة أفراد">    </p:cNvPr>
           <p:cNvPicPr>
             <a:picLocks noChangeAspect="1"/>
           </p:cNvPicPr>
@@ -11461,7 +11401,7 @@
       </p:pic>
       <p:sp>
         <p:nvSpPr>
-          <p:cNvPr id="11" name="anim1_27"/>
+          <p:cNvPr id="11" name="anim1_26"/>
           <p:cNvSpPr txBox="1"/>
           <p:nvPr/>
         </p:nvSpPr>
@@ -11500,7 +11440,7 @@
       </p:sp>
       <p:sp>
         <p:nvSpPr>
-          <p:cNvPr id="12" name="anim1_28"/>
+          <p:cNvPr id="12" name="anim1_27"/>
           <p:cNvSpPr txBox="1"/>
           <p:nvPr/>
         </p:nvSpPr>
@@ -11539,7 +11479,7 @@
       </p:sp>
       <p:sp>
         <p:nvSpPr>
-          <p:cNvPr id="13" name="anim1_29"/>
+          <p:cNvPr id="13" name="anim1_28"/>
           <p:cNvSpPr txBox="1"/>
           <p:nvPr/>
         </p:nvSpPr>
@@ -11595,7 +11535,7 @@
       </p:sp>
       <p:sp>
         <p:nvSpPr>
-          <p:cNvPr id="14" name="anim2_30"/>
+          <p:cNvPr id="14" name="anim2_29"/>
           <p:cNvSpPr/>
           <p:nvPr/>
         </p:nvSpPr>
@@ -11617,7 +11557,7 @@
       </p:sp>
       <p:sp>
         <p:nvSpPr>
-          <p:cNvPr id="15" name="anim2_31"/>
+          <p:cNvPr id="15" name="anim2_30"/>
           <p:cNvSpPr/>
           <p:nvPr/>
         </p:nvSpPr>
@@ -11637,7 +11577,7 @@
       </p:sp>
       <p:pic>
         <p:nvPicPr>
-          <p:cNvPr id="16" name="anim2_32" descr="نافذة أفراد">    </p:cNvPr>
+          <p:cNvPr id="16" name="anim2_31" descr="نافذة أفراد">    </p:cNvPr>
           <p:cNvPicPr>
             <a:picLocks noChangeAspect="1"/>
           </p:cNvPicPr>
@@ -11651,8 +11591,8 @@
         </p:blipFill>
         <p:spPr>
           <a:xfrm>
-            <a:off x="7048195" y="2559562"/>
-            <a:ext cx="960120" cy="641597"/>
+            <a:off x="7048195" y="2583481"/>
+            <a:ext cx="960120" cy="593758"/>
           </a:xfrm>
           <a:prstGeom prst="rect">
             <a:avLst/>
@@ -11661,7 +11601,7 @@
       </p:pic>
       <p:sp>
         <p:nvSpPr>
-          <p:cNvPr id="17" name="anim2_33"/>
+          <p:cNvPr id="17" name="anim2_32"/>
           <p:cNvSpPr txBox="1"/>
           <p:nvPr/>
         </p:nvSpPr>
@@ -11700,7 +11640,7 @@
       </p:sp>
       <p:sp>
         <p:nvSpPr>
-          <p:cNvPr id="18" name="anim2_34"/>
+          <p:cNvPr id="18" name="anim2_33"/>
           <p:cNvSpPr txBox="1"/>
           <p:nvPr/>
         </p:nvSpPr>
@@ -11739,7 +11679,7 @@
       </p:sp>
       <p:sp>
         <p:nvSpPr>
-          <p:cNvPr id="19" name="anim2_35"/>
+          <p:cNvPr id="19" name="anim2_34"/>
           <p:cNvSpPr txBox="1"/>
           <p:nvPr/>
         </p:nvSpPr>
@@ -11795,7 +11735,7 @@
       </p:sp>
       <p:sp>
         <p:nvSpPr>
-          <p:cNvPr id="20" name="anim3_36"/>
+          <p:cNvPr id="20" name="anim3_35"/>
           <p:cNvSpPr/>
           <p:nvPr/>
         </p:nvSpPr>
@@ -11817,7 +11757,7 @@
       </p:sp>
       <p:sp>
         <p:nvSpPr>
-          <p:cNvPr id="21" name="anim3_37"/>
+          <p:cNvPr id="21" name="anim3_36"/>
           <p:cNvSpPr/>
           <p:nvPr/>
         </p:nvSpPr>
@@ -11837,7 +11777,7 @@
       </p:sp>
       <p:pic>
         <p:nvPicPr>
-          <p:cNvPr id="22" name="anim3_38" descr="نافذة أفراد">    </p:cNvPr>
+          <p:cNvPr id="22" name="anim3_37" descr="نافذة أفراد">    </p:cNvPr>
           <p:cNvPicPr>
             <a:picLocks noChangeAspect="1"/>
           </p:cNvPicPr>
@@ -11861,7 +11801,7 @@
       </p:pic>
       <p:sp>
         <p:nvSpPr>
-          <p:cNvPr id="23" name="anim3_39"/>
+          <p:cNvPr id="23" name="anim3_38"/>
           <p:cNvSpPr txBox="1"/>
           <p:nvPr/>
         </p:nvSpPr>
@@ -11900,7 +11840,7 @@
       </p:sp>
       <p:sp>
         <p:nvSpPr>
-          <p:cNvPr id="24" name="anim3_40"/>
+          <p:cNvPr id="24" name="anim3_39"/>
           <p:cNvSpPr txBox="1"/>
           <p:nvPr/>
         </p:nvSpPr>
@@ -11939,7 +11879,7 @@
       </p:sp>
       <p:sp>
         <p:nvSpPr>
-          <p:cNvPr id="25" name="anim3_41"/>
+          <p:cNvPr id="25" name="anim3_40"/>
           <p:cNvSpPr txBox="1"/>
           <p:nvPr/>
         </p:nvSpPr>
@@ -11995,7 +11935,7 @@
       </p:sp>
       <p:sp>
         <p:nvSpPr>
-          <p:cNvPr id="26" name="anim4_42"/>
+          <p:cNvPr id="26" name="anim4_41"/>
           <p:cNvSpPr/>
           <p:nvPr/>
         </p:nvSpPr>
@@ -12017,7 +11957,7 @@
       </p:sp>
       <p:sp>
         <p:nvSpPr>
-          <p:cNvPr id="27" name="anim4_43"/>
+          <p:cNvPr id="27" name="anim4_42"/>
           <p:cNvSpPr/>
           <p:nvPr/>
         </p:nvSpPr>
@@ -12037,7 +11977,7 @@
       </p:sp>
       <p:pic>
         <p:nvPicPr>
-          <p:cNvPr id="28" name="anim4_44" descr="نافذة أفراد">    </p:cNvPr>
+          <p:cNvPr id="28" name="anim4_43" descr="نافذة أفراد">    </p:cNvPr>
           <p:cNvPicPr>
             <a:picLocks noChangeAspect="1"/>
           </p:cNvPicPr>
@@ -12061,7 +12001,7 @@
       </p:pic>
       <p:sp>
         <p:nvSpPr>
-          <p:cNvPr id="29" name="anim4_45"/>
+          <p:cNvPr id="29" name="anim4_44"/>
           <p:cNvSpPr txBox="1"/>
           <p:nvPr/>
         </p:nvSpPr>
@@ -12100,7 +12040,7 @@
       </p:sp>
       <p:sp>
         <p:nvSpPr>
-          <p:cNvPr id="30" name="anim4_46"/>
+          <p:cNvPr id="30" name="anim4_45"/>
           <p:cNvSpPr txBox="1"/>
           <p:nvPr/>
         </p:nvSpPr>
@@ -12139,7 +12079,7 @@
       </p:sp>
       <p:sp>
         <p:nvSpPr>
-          <p:cNvPr id="31" name="anim4_47"/>
+          <p:cNvPr id="31" name="anim4_46"/>
           <p:cNvSpPr txBox="1"/>
           <p:nvPr/>
         </p:nvSpPr>
@@ -12195,7 +12135,7 @@
       </p:sp>
       <p:sp>
         <p:nvSpPr>
-          <p:cNvPr id="32" name="anim5_48"/>
+          <p:cNvPr id="32" name="anim5_47"/>
           <p:cNvSpPr txBox="1"/>
           <p:nvPr/>
         </p:nvSpPr>
@@ -13460,7 +13400,7 @@
       </p:sp>
       <p:sp>
         <p:nvSpPr>
-          <p:cNvPr id="8" name="anim1_49"/>
+          <p:cNvPr id="8" name="anim1_48"/>
           <p:cNvSpPr/>
           <p:nvPr/>
         </p:nvSpPr>
@@ -13480,7 +13420,7 @@
       </p:sp>
       <p:pic>
         <p:nvPicPr>
-          <p:cNvPr id="9" name="anim1_50" descr="نافذة أفراد">    </p:cNvPr>
+          <p:cNvPr id="9" name="anim1_49" descr="نافذة أفراد">    </p:cNvPr>
           <p:cNvPicPr>
             <a:picLocks noChangeAspect="1"/>
           </p:cNvPicPr>
@@ -13504,7 +13444,7 @@
       </p:pic>
       <p:sp>
         <p:nvSpPr>
-          <p:cNvPr id="10" name="anim1_51"/>
+          <p:cNvPr id="10" name="anim1_50"/>
           <p:cNvSpPr txBox="1"/>
           <p:nvPr/>
         </p:nvSpPr>
@@ -13543,7 +13483,7 @@
       </p:sp>
       <p:sp>
         <p:nvSpPr>
-          <p:cNvPr id="11" name="anim2_52"/>
+          <p:cNvPr id="11" name="anim2_51"/>
           <p:cNvSpPr/>
           <p:nvPr/>
         </p:nvSpPr>
@@ -13567,7 +13507,7 @@
       </p:sp>
       <p:sp>
         <p:nvSpPr>
-          <p:cNvPr id="12" name="anim1_53"/>
+          <p:cNvPr id="12" name="anim1_52"/>
           <p:cNvSpPr/>
           <p:nvPr/>
         </p:nvSpPr>
@@ -13587,7 +13527,7 @@
       </p:sp>
       <p:pic>
         <p:nvPicPr>
-          <p:cNvPr id="13" name="anim1_54" descr="نافذة أفراد">    </p:cNvPr>
+          <p:cNvPr id="13" name="anim1_53" descr="نافذة أفراد">    </p:cNvPr>
           <p:cNvPicPr>
             <a:picLocks noChangeAspect="1"/>
           </p:cNvPicPr>
@@ -13601,8 +13541,8 @@
         </p:blipFill>
         <p:spPr>
           <a:xfrm>
-            <a:off x="1088136" y="2142296"/>
-            <a:ext cx="566928" cy="378848"/>
+            <a:off x="1088136" y="2156420"/>
+            <a:ext cx="566928" cy="350600"/>
           </a:xfrm>
           <a:prstGeom prst="rect">
             <a:avLst/>
@@ -13611,7 +13551,7 @@
       </p:pic>
       <p:sp>
         <p:nvSpPr>
-          <p:cNvPr id="14" name="anim1_55"/>
+          <p:cNvPr id="14" name="anim1_54"/>
           <p:cNvSpPr txBox="1"/>
           <p:nvPr/>
         </p:nvSpPr>
@@ -13650,7 +13590,7 @@
       </p:sp>
       <p:sp>
         <p:nvSpPr>
-          <p:cNvPr id="15" name="anim2_56"/>
+          <p:cNvPr id="15" name="anim2_55"/>
           <p:cNvSpPr/>
           <p:nvPr/>
         </p:nvSpPr>
@@ -13674,7 +13614,7 @@
       </p:sp>
       <p:sp>
         <p:nvSpPr>
-          <p:cNvPr id="16" name="anim1_57"/>
+          <p:cNvPr id="16" name="anim1_56"/>
           <p:cNvSpPr/>
           <p:nvPr/>
         </p:nvSpPr>
@@ -13694,7 +13634,7 @@
       </p:sp>
       <p:pic>
         <p:nvPicPr>
-          <p:cNvPr id="17" name="anim1_58" descr="نافذة أفراد">    </p:cNvPr>
+          <p:cNvPr id="17" name="anim1_57" descr="نافذة أفراد">    </p:cNvPr>
           <p:cNvPicPr>
             <a:picLocks noChangeAspect="1"/>
           </p:cNvPicPr>
@@ -13718,7 +13658,7 @@
       </p:pic>
       <p:sp>
         <p:nvSpPr>
-          <p:cNvPr id="18" name="anim1_59"/>
+          <p:cNvPr id="18" name="anim1_58"/>
           <p:cNvSpPr txBox="1"/>
           <p:nvPr/>
         </p:nvSpPr>
@@ -13757,7 +13697,7 @@
       </p:sp>
       <p:sp>
         <p:nvSpPr>
-          <p:cNvPr id="19" name="anim2_60"/>
+          <p:cNvPr id="19" name="anim2_59"/>
           <p:cNvSpPr/>
           <p:nvPr/>
         </p:nvSpPr>
@@ -13781,7 +13721,7 @@
       </p:sp>
       <p:sp>
         <p:nvSpPr>
-          <p:cNvPr id="20" name="anim1_61"/>
+          <p:cNvPr id="20" name="anim1_60"/>
           <p:cNvSpPr/>
           <p:nvPr/>
         </p:nvSpPr>
@@ -13801,7 +13741,7 @@
       </p:sp>
       <p:pic>
         <p:nvPicPr>
-          <p:cNvPr id="21" name="anim1_62" descr="نافذة أفراد">    </p:cNvPr>
+          <p:cNvPr id="21" name="anim1_61" descr="نافذة أفراد">    </p:cNvPr>
           <p:cNvPicPr>
             <a:picLocks noChangeAspect="1"/>
           </p:cNvPicPr>
@@ -13825,7 +13765,7 @@
       </p:pic>
       <p:sp>
         <p:nvSpPr>
-          <p:cNvPr id="22" name="anim1_63"/>
+          <p:cNvPr id="22" name="anim1_62"/>
           <p:cNvSpPr txBox="1"/>
           <p:nvPr/>
         </p:nvSpPr>
@@ -13864,7 +13804,7 @@
       </p:sp>
       <p:sp>
         <p:nvSpPr>
-          <p:cNvPr id="23" name="anim2_64"/>
+          <p:cNvPr id="23" name="anim2_63"/>
           <p:cNvSpPr/>
           <p:nvPr/>
         </p:nvSpPr>
@@ -13888,7 +13828,7 @@
       </p:sp>
       <p:pic>
         <p:nvPicPr>
-          <p:cNvPr id="24" name="anim3_65" descr="نافذة أفراد">    </p:cNvPr>
+          <p:cNvPr id="24" name="anim3_64" descr="نافذة أفراد">    </p:cNvPr>
           <p:cNvPicPr>
             <a:picLocks noChangeAspect="1"/>
           </p:cNvPicPr>
@@ -13912,7 +13852,7 @@
       </p:pic>
       <p:sp>
         <p:nvSpPr>
-          <p:cNvPr id="25" name="anim4_66"/>
+          <p:cNvPr id="25" name="anim4_65"/>
           <p:cNvSpPr/>
           <p:nvPr/>
         </p:nvSpPr>
@@ -13932,7 +13872,7 @@
       </p:sp>
       <p:pic>
         <p:nvPicPr>
-          <p:cNvPr id="26" name="anim4_67" descr="نافذة أفراد">    </p:cNvPr>
+          <p:cNvPr id="26" name="anim4_66" descr="نافذة أفراد">    </p:cNvPr>
           <p:cNvPicPr>
             <a:picLocks noChangeAspect="1"/>
           </p:cNvPicPr>
@@ -13956,7 +13896,7 @@
       </p:pic>
       <p:sp>
         <p:nvSpPr>
-          <p:cNvPr id="27" name="anim4_68"/>
+          <p:cNvPr id="27" name="anim4_67"/>
           <p:cNvSpPr txBox="1"/>
           <p:nvPr/>
         </p:nvSpPr>
@@ -13995,7 +13935,7 @@
       </p:sp>
       <p:sp>
         <p:nvSpPr>
-          <p:cNvPr id="28" name="anim4_69"/>
+          <p:cNvPr id="28" name="anim4_68"/>
           <p:cNvSpPr txBox="1"/>
           <p:nvPr/>
         </p:nvSpPr>
@@ -14034,7 +13974,7 @@
       </p:sp>
       <p:sp>
         <p:nvSpPr>
-          <p:cNvPr id="29" name="anim5_70"/>
+          <p:cNvPr id="29" name="anim5_69"/>
           <p:cNvSpPr/>
           <p:nvPr/>
         </p:nvSpPr>
@@ -14054,7 +13994,7 @@
       </p:sp>
       <p:pic>
         <p:nvPicPr>
-          <p:cNvPr id="30" name="anim5_71" descr="نافذة أفراد">    </p:cNvPr>
+          <p:cNvPr id="30" name="anim5_70" descr="نافذة أفراد">    </p:cNvPr>
           <p:cNvPicPr>
             <a:picLocks noChangeAspect="1"/>
           </p:cNvPicPr>
@@ -14078,7 +14018,7 @@
       </p:pic>
       <p:sp>
         <p:nvSpPr>
-          <p:cNvPr id="31" name="anim5_72"/>
+          <p:cNvPr id="31" name="anim5_71"/>
           <p:cNvSpPr txBox="1"/>
           <p:nvPr/>
         </p:nvSpPr>
@@ -14117,7 +14057,7 @@
       </p:sp>
       <p:sp>
         <p:nvSpPr>
-          <p:cNvPr id="32" name="anim5_73"/>
+          <p:cNvPr id="32" name="anim5_72"/>
           <p:cNvSpPr txBox="1"/>
           <p:nvPr/>
         </p:nvSpPr>
@@ -14156,7 +14096,7 @@
       </p:sp>
       <p:sp>
         <p:nvSpPr>
-          <p:cNvPr id="33" name="anim6_74"/>
+          <p:cNvPr id="33" name="anim6_73"/>
           <p:cNvSpPr/>
           <p:nvPr/>
         </p:nvSpPr>
@@ -14176,7 +14116,7 @@
       </p:sp>
       <p:pic>
         <p:nvPicPr>
-          <p:cNvPr id="34" name="anim6_75" descr="نافذة أفراد">    </p:cNvPr>
+          <p:cNvPr id="34" name="anim6_74" descr="نافذة أفراد">    </p:cNvPr>
           <p:cNvPicPr>
             <a:picLocks noChangeAspect="1"/>
           </p:cNvPicPr>
@@ -14200,7 +14140,7 @@
       </p:pic>
       <p:sp>
         <p:nvSpPr>
-          <p:cNvPr id="35" name="anim6_76"/>
+          <p:cNvPr id="35" name="anim6_75"/>
           <p:cNvSpPr txBox="1"/>
           <p:nvPr/>
         </p:nvSpPr>
@@ -14239,7 +14179,7 @@
       </p:sp>
       <p:sp>
         <p:nvSpPr>
-          <p:cNvPr id="36" name="anim6_77"/>
+          <p:cNvPr id="36" name="anim6_76"/>
           <p:cNvSpPr txBox="1"/>
           <p:nvPr/>
         </p:nvSpPr>
@@ -14278,7 +14218,7 @@
       </p:sp>
       <p:sp>
         <p:nvSpPr>
-          <p:cNvPr id="37" name="anim7_78"/>
+          <p:cNvPr id="37" name="anim7_77"/>
           <p:cNvSpPr/>
           <p:nvPr/>
         </p:nvSpPr>
@@ -14300,7 +14240,7 @@
       </p:sp>
       <p:sp>
         <p:nvSpPr>
-          <p:cNvPr id="38" name="anim7_79"/>
+          <p:cNvPr id="38" name="anim7_78"/>
           <p:cNvSpPr txBox="1"/>
           <p:nvPr/>
         </p:nvSpPr>
@@ -15795,7 +15735,7 @@
       </p:sp>
       <p:sp>
         <p:nvSpPr>
-          <p:cNvPr id="8" name="anim1_80"/>
+          <p:cNvPr id="8" name="anim1_79"/>
           <p:cNvSpPr/>
           <p:nvPr/>
         </p:nvSpPr>
@@ -15817,7 +15757,7 @@
       </p:sp>
       <p:pic>
         <p:nvPicPr>
-          <p:cNvPr id="9" name="anim1_81" descr="نافذة أفراد">    </p:cNvPr>
+          <p:cNvPr id="9" name="anim1_80" descr="نافذة أفراد">    </p:cNvPr>
           <p:cNvPicPr>
             <a:picLocks noChangeAspect="1"/>
           </p:cNvPicPr>
@@ -15843,7 +15783,7 @@
       </p:pic>
       <p:sp>
         <p:nvSpPr>
-          <p:cNvPr id="10" name="anim1_82"/>
+          <p:cNvPr id="10" name="anim1_81"/>
           <p:cNvSpPr txBox="1"/>
           <p:nvPr/>
         </p:nvSpPr>
@@ -15882,7 +15822,7 @@
       </p:sp>
       <p:sp>
         <p:nvSpPr>
-          <p:cNvPr id="11" name="anim1_83"/>
+          <p:cNvPr id="11" name="anim1_82"/>
           <p:cNvSpPr txBox="1"/>
           <p:nvPr/>
         </p:nvSpPr>
@@ -15921,7 +15861,7 @@
       </p:sp>
       <p:sp>
         <p:nvSpPr>
-          <p:cNvPr id="12" name="anim1_84"/>
+          <p:cNvPr id="12" name="anim1_83"/>
           <p:cNvSpPr txBox="1"/>
           <p:nvPr/>
         </p:nvSpPr>
@@ -15960,7 +15900,7 @@
       </p:sp>
       <p:sp>
         <p:nvSpPr>
-          <p:cNvPr id="13" name="anim2_85"/>
+          <p:cNvPr id="13" name="anim2_84"/>
           <p:cNvSpPr/>
           <p:nvPr/>
         </p:nvSpPr>
@@ -15982,7 +15922,7 @@
       </p:sp>
       <p:pic>
         <p:nvPicPr>
-          <p:cNvPr id="14" name="anim2_86" descr="نافذة أفراد">    </p:cNvPr>
+          <p:cNvPr id="14" name="anim2_85" descr="نافذة أفراد">    </p:cNvPr>
           <p:cNvPicPr>
             <a:picLocks noChangeAspect="1"/>
           </p:cNvPicPr>
@@ -16008,7 +15948,7 @@
       </p:pic>
       <p:sp>
         <p:nvSpPr>
-          <p:cNvPr id="15" name="anim2_87"/>
+          <p:cNvPr id="15" name="anim2_86"/>
           <p:cNvSpPr txBox="1"/>
           <p:nvPr/>
         </p:nvSpPr>
@@ -16047,7 +15987,7 @@
       </p:sp>
       <p:sp>
         <p:nvSpPr>
-          <p:cNvPr id="16" name="anim2_88"/>
+          <p:cNvPr id="16" name="anim2_87"/>
           <p:cNvSpPr txBox="1"/>
           <p:nvPr/>
         </p:nvSpPr>
@@ -16086,7 +16026,7 @@
       </p:sp>
       <p:sp>
         <p:nvSpPr>
-          <p:cNvPr id="17" name="anim2_89"/>
+          <p:cNvPr id="17" name="anim2_88"/>
           <p:cNvSpPr txBox="1"/>
           <p:nvPr/>
         </p:nvSpPr>
@@ -16123,16 +16063,40 @@
           </a:p>
         </p:txBody>
       </p:sp>
-      <p:sp>
-        <p:nvSpPr>
-          <p:cNvPr id="18" name="anim3_90"/>
+      <p:pic>
+        <p:nvPicPr>
+          <p:cNvPr id="18" name="anim3_89" descr="شعار الهيئة الملكية للجبيل وينبع">    </p:cNvPr>
+          <p:cNvPicPr>
+            <a:picLocks noChangeAspect="1"/>
+          </p:cNvPicPr>
+          <p:nvPr/>
+        </p:nvPicPr>
+        <p:blipFill>
+          <a:blip r:embed="rId5"/>
+          <a:stretch>
+            <a:fillRect/>
+          </a:stretch>
+        </p:blipFill>
+        <p:spPr>
+          <a:xfrm>
+            <a:off x="10895235" y="5303520"/>
+            <a:ext cx="747821" cy="566928"/>
+          </a:xfrm>
+          <a:prstGeom prst="rect">
+            <a:avLst/>
+          </a:prstGeom>
+        </p:spPr>
+      </p:pic>
+      <p:sp>
+        <p:nvSpPr>
+          <p:cNvPr id="19" name="anim3_90"/>
           <p:cNvSpPr txBox="1"/>
           <p:nvPr/>
         </p:nvSpPr>
         <p:spPr>
           <a:xfrm>
-            <a:off x="548640" y="5349240"/>
-            <a:ext cx="11094415" cy="411480"/>
+            <a:off x="548640" y="5303520"/>
+            <a:ext cx="10117995" cy="566928"/>
           </a:xfrm>
           <a:prstGeom prst="rect">
             <a:avLst/>
@@ -16141,7 +16105,7 @@
           <a:ln/>
         </p:spPr>
         <p:txBody>
-          <a:bodyPr wrap="square" lIns="0" tIns="0" rIns="0" bIns="0" rtlCol="0" anchor="t"/>
+          <a:bodyPr wrap="square" lIns="0" tIns="0" rIns="0" bIns="0" rtlCol="0" anchor="ctr"/>
           <a:lstStyle/>
           <a:p>
             <a:pPr rtl="1" algn="r" indent="0" marL="0">
@@ -16179,7 +16143,7 @@
               <p:cTn id="2" dur="indefinite" nodeType="mainSeq">
                 <p:childTnLst>
                   <p:par>
-                    <p:cTn id="39" fill="hold">
+                    <p:cTn id="42" fill="hold">
                       <p:stCondLst>
                         <p:cond delay="indefinite"/>
                         <p:cond evt="onBegin" delay="0">
@@ -16556,7 +16520,7 @@
                           </p:cTn>
                         </p:par>
                         <p:par>
-                          <p:cTn id="38" fill="hold">
+                          <p:cTn id="41" fill="hold">
                             <p:stCondLst>
                               <p:cond delay="1400"/>
                             </p:stCondLst>
@@ -16590,6 +16554,41 @@
                                         <p:cTn id="37" dur="450"/>
                                         <p:tgtEl>
                                           <p:spTgt spid="18"/>
+                                        </p:tgtEl>
+                                      </p:cBhvr>
+                                    </p:animEffect>
+                                  </p:childTnLst>
+                                </p:cTn>
+                              </p:par>
+                              <p:par>
+                                <p:cTn id="38" presetID="10" presetClass="entr" presetSubtype="0" fill="hold" grpId="0" nodeType="withEffect">
+                                  <p:stCondLst>
+                                    <p:cond delay="0"/>
+                                  </p:stCondLst>
+                                  <p:childTnLst>
+                                    <p:set>
+                                      <p:cBhvr>
+                                        <p:cTn id="39" dur="1" fill="hold">
+                                          <p:stCondLst>
+                                            <p:cond delay="0"/>
+                                          </p:stCondLst>
+                                        </p:cTn>
+                                        <p:tgtEl>
+                                          <p:spTgt spid="19"/>
+                                        </p:tgtEl>
+                                        <p:attrNameLst>
+                                          <p:attrName>style.visibility</p:attrName>
+                                        </p:attrNameLst>
+                                      </p:cBhvr>
+                                      <p:to>
+                                        <p:strVal val="visible"/>
+                                      </p:to>
+                                    </p:set>
+                                    <p:animEffect transition="in" filter="fade">
+                                      <p:cBhvr>
+                                        <p:cTn id="40" dur="450"/>
+                                        <p:tgtEl>
+                                          <p:spTgt spid="19"/>
                                         </p:tgtEl>
                                       </p:cBhvr>
                                     </p:animEffect>
@@ -16632,7 +16631,7 @@
       <p:bldP spid="15" grpId="0" animBg="1"/>
       <p:bldP spid="16" grpId="0" animBg="1"/>
       <p:bldP spid="17" grpId="0" animBg="1"/>
-      <p:bldP spid="18" grpId="0" animBg="1"/>
+      <p:bldP spid="19" grpId="0" animBg="1"/>
     </p:bldLst>
   </p:timing>
 </p:sld>

</xml_diff>